<commit_message>
feat: compile verified 12-page PDF pitch deck and update team rosters
</commit_message>
<xml_diff>
--- a/GridOS_Pitch_Deck_Complete.pptx
+++ b/GridOS_Pitch_Deck_Complete.pptx
@@ -5,20 +5,20 @@
     <p:sldMasterId id="2147483648" r:id="rId1"/>
   </p:sldMasterIdLst>
   <p:sldIdLst>
-    <p:sldId id="256" r:id="rId2"/>
-    <p:sldId id="257" r:id="rId3"/>
-    <p:sldId id="258" r:id="rId4"/>
-    <p:sldId id="259" r:id="rId5"/>
-    <p:sldId id="260" r:id="rId6"/>
-    <p:sldId id="261" r:id="rId7"/>
-    <p:sldId id="262" r:id="rId8"/>
-    <p:sldId id="263" r:id="rId9"/>
-    <p:sldId id="264" r:id="rId10"/>
-    <p:sldId id="265" r:id="rId11"/>
-    <p:sldId id="266" r:id="rId12"/>
-    <p:sldId id="267" r:id="rId13"/>
+    <p:sldId id="256" r:id="rId7"/>
+    <p:sldId id="257" r:id="rId8"/>
+    <p:sldId id="258" r:id="rId9"/>
+    <p:sldId id="259" r:id="rId10"/>
+    <p:sldId id="260" r:id="rId11"/>
+    <p:sldId id="261" r:id="rId12"/>
+    <p:sldId id="262" r:id="rId13"/>
+    <p:sldId id="263" r:id="rId14"/>
+    <p:sldId id="264" r:id="rId15"/>
+    <p:sldId id="265" r:id="rId16"/>
+    <p:sldId id="266" r:id="rId17"/>
+    <p:sldId id="267" r:id="rId18"/>
   </p:sldIdLst>
-  <p:sldSz cx="12192000" cy="6858000"/>
+  <p:sldSz cx="12191695" cy="6858000" type="screen4x3"/>
   <p:notesSz cx="6858000" cy="9144000"/>
   <p:defaultTextStyle>
     <a:defPPr>
@@ -115,22 +115,6 @@
       </a:defRPr>
     </a:lvl9pPr>
   </p:defaultTextStyle>
-  <p:extLst>
-    <p:ext uri="{EFAFB233-063F-42B5-8137-9DF3F51BA10A}">
-      <p15:sldGuideLst xmlns:p15="http://schemas.microsoft.com/office/powerpoint/2012/main">
-        <p15:guide id="1" orient="horz" pos="2160">
-          <p15:clr>
-            <a:srgbClr val="A4A3A4"/>
-          </p15:clr>
-        </p15:guide>
-        <p15:guide id="2" pos="2880">
-          <p15:clr>
-            <a:srgbClr val="A4A3A4"/>
-          </p15:clr>
-        </p15:guide>
-      </p15:sldGuideLst>
-    </p:ext>
-  </p:extLst>
 </p:presentation>
 </file>
 
@@ -172,9 +156,10 @@
           <a:lstStyle/>
           <a:p>
             <a:r>
-              <a:rPr lang="en-US"/>
+              <a:rPr lang="en-US" smtClean="0"/>
               <a:t>Click to edit Master title style</a:t>
             </a:r>
+            <a:endParaRPr lang="en-US"/>
           </a:p>
         </p:txBody>
       </p:sp>
@@ -290,9 +275,10 @@
           </a:lstStyle>
           <a:p>
             <a:r>
-              <a:rPr lang="en-US"/>
+              <a:rPr lang="en-US" smtClean="0"/>
               <a:t>Click to edit Master subtitle style</a:t>
             </a:r>
+            <a:endParaRPr lang="en-US"/>
           </a:p>
         </p:txBody>
       </p:sp>
@@ -313,7 +299,7 @@
           <a:p>
             <a:fld id="{5BCAD085-E8A6-8845-BD4E-CB4CCA059FC4}" type="datetimeFigureOut">
               <a:rPr lang="en-US" smtClean="0"/>
-              <a:t>10/9/2026</a:t>
+              <a:t>1/27/13</a:t>
             </a:fld>
             <a:endParaRPr lang="en-US"/>
           </a:p>
@@ -407,9 +393,10 @@
           <a:lstStyle/>
           <a:p>
             <a:r>
-              <a:rPr lang="en-US"/>
+              <a:rPr lang="en-US" smtClean="0"/>
               <a:t>Click to edit Master title style</a:t>
             </a:r>
+            <a:endParaRPr lang="en-US"/>
           </a:p>
         </p:txBody>
       </p:sp>
@@ -430,37 +417,38 @@
           <a:p>
             <a:pPr lvl="0"/>
             <a:r>
-              <a:rPr lang="en-US"/>
+              <a:rPr lang="en-US" smtClean="0"/>
               <a:t>Click to edit Master text styles</a:t>
             </a:r>
           </a:p>
           <a:p>
             <a:pPr lvl="1"/>
             <a:r>
-              <a:rPr lang="en-US"/>
+              <a:rPr lang="en-US" smtClean="0"/>
               <a:t>Second level</a:t>
             </a:r>
           </a:p>
           <a:p>
             <a:pPr lvl="2"/>
             <a:r>
-              <a:rPr lang="en-US"/>
+              <a:rPr lang="en-US" smtClean="0"/>
               <a:t>Third level</a:t>
             </a:r>
           </a:p>
           <a:p>
             <a:pPr lvl="3"/>
             <a:r>
-              <a:rPr lang="en-US"/>
+              <a:rPr lang="en-US" smtClean="0"/>
               <a:t>Fourth level</a:t>
             </a:r>
           </a:p>
           <a:p>
             <a:pPr lvl="4"/>
             <a:r>
-              <a:rPr lang="en-US"/>
+              <a:rPr lang="en-US" smtClean="0"/>
               <a:t>Fifth level</a:t>
             </a:r>
+            <a:endParaRPr lang="en-US"/>
           </a:p>
         </p:txBody>
       </p:sp>
@@ -481,7 +469,7 @@
           <a:p>
             <a:fld id="{5BCAD085-E8A6-8845-BD4E-CB4CCA059FC4}" type="datetimeFigureOut">
               <a:rPr lang="en-US" smtClean="0"/>
-              <a:t>10/9/2026</a:t>
+              <a:t>1/27/13</a:t>
             </a:fld>
             <a:endParaRPr lang="en-US"/>
           </a:p>
@@ -580,9 +568,10 @@
           <a:lstStyle/>
           <a:p>
             <a:r>
-              <a:rPr lang="en-US"/>
+              <a:rPr lang="en-US" smtClean="0"/>
               <a:t>Click to edit Master title style</a:t>
             </a:r>
+            <a:endParaRPr lang="en-US"/>
           </a:p>
         </p:txBody>
       </p:sp>
@@ -608,37 +597,38 @@
           <a:p>
             <a:pPr lvl="0"/>
             <a:r>
-              <a:rPr lang="en-US"/>
+              <a:rPr lang="en-US" smtClean="0"/>
               <a:t>Click to edit Master text styles</a:t>
             </a:r>
           </a:p>
           <a:p>
             <a:pPr lvl="1"/>
             <a:r>
-              <a:rPr lang="en-US"/>
+              <a:rPr lang="en-US" smtClean="0"/>
               <a:t>Second level</a:t>
             </a:r>
           </a:p>
           <a:p>
             <a:pPr lvl="2"/>
             <a:r>
-              <a:rPr lang="en-US"/>
+              <a:rPr lang="en-US" smtClean="0"/>
               <a:t>Third level</a:t>
             </a:r>
           </a:p>
           <a:p>
             <a:pPr lvl="3"/>
             <a:r>
-              <a:rPr lang="en-US"/>
+              <a:rPr lang="en-US" smtClean="0"/>
               <a:t>Fourth level</a:t>
             </a:r>
           </a:p>
           <a:p>
             <a:pPr lvl="4"/>
             <a:r>
-              <a:rPr lang="en-US"/>
+              <a:rPr lang="en-US" smtClean="0"/>
               <a:t>Fifth level</a:t>
             </a:r>
+            <a:endParaRPr lang="en-US"/>
           </a:p>
         </p:txBody>
       </p:sp>
@@ -659,7 +649,7 @@
           <a:p>
             <a:fld id="{5BCAD085-E8A6-8845-BD4E-CB4CCA059FC4}" type="datetimeFigureOut">
               <a:rPr lang="en-US" smtClean="0"/>
-              <a:t>10/9/2026</a:t>
+              <a:t>1/27/13</a:t>
             </a:fld>
             <a:endParaRPr lang="en-US"/>
           </a:p>
@@ -753,9 +743,10 @@
           <a:lstStyle/>
           <a:p>
             <a:r>
-              <a:rPr lang="en-US"/>
+              <a:rPr lang="en-US" smtClean="0"/>
               <a:t>Click to edit Master title style</a:t>
             </a:r>
+            <a:endParaRPr lang="en-US"/>
           </a:p>
         </p:txBody>
       </p:sp>
@@ -776,37 +767,38 @@
           <a:p>
             <a:pPr lvl="0"/>
             <a:r>
-              <a:rPr lang="en-US"/>
+              <a:rPr lang="en-US" smtClean="0"/>
               <a:t>Click to edit Master text styles</a:t>
             </a:r>
           </a:p>
           <a:p>
             <a:pPr lvl="1"/>
             <a:r>
-              <a:rPr lang="en-US"/>
+              <a:rPr lang="en-US" smtClean="0"/>
               <a:t>Second level</a:t>
             </a:r>
           </a:p>
           <a:p>
             <a:pPr lvl="2"/>
             <a:r>
-              <a:rPr lang="en-US"/>
+              <a:rPr lang="en-US" smtClean="0"/>
               <a:t>Third level</a:t>
             </a:r>
           </a:p>
           <a:p>
             <a:pPr lvl="3"/>
             <a:r>
-              <a:rPr lang="en-US"/>
+              <a:rPr lang="en-US" smtClean="0"/>
               <a:t>Fourth level</a:t>
             </a:r>
           </a:p>
           <a:p>
             <a:pPr lvl="4"/>
             <a:r>
-              <a:rPr lang="en-US"/>
+              <a:rPr lang="en-US" smtClean="0"/>
               <a:t>Fifth level</a:t>
             </a:r>
+            <a:endParaRPr lang="en-US"/>
           </a:p>
         </p:txBody>
       </p:sp>
@@ -827,7 +819,7 @@
           <a:p>
             <a:fld id="{5BCAD085-E8A6-8845-BD4E-CB4CCA059FC4}" type="datetimeFigureOut">
               <a:rPr lang="en-US" smtClean="0"/>
-              <a:t>10/9/2026</a:t>
+              <a:t>1/27/13</a:t>
             </a:fld>
             <a:endParaRPr lang="en-US"/>
           </a:p>
@@ -930,9 +922,10 @@
           </a:lstStyle>
           <a:p>
             <a:r>
-              <a:rPr lang="en-US"/>
+              <a:rPr lang="en-US" smtClean="0"/>
               <a:t>Click to edit Master title style</a:t>
             </a:r>
+            <a:endParaRPr lang="en-US"/>
           </a:p>
         </p:txBody>
       </p:sp>
@@ -1049,7 +1042,7 @@
           <a:p>
             <a:pPr lvl="0"/>
             <a:r>
-              <a:rPr lang="en-US"/>
+              <a:rPr lang="en-US" smtClean="0"/>
               <a:t>Click to edit Master text styles</a:t>
             </a:r>
           </a:p>
@@ -1072,7 +1065,7 @@
           <a:p>
             <a:fld id="{5BCAD085-E8A6-8845-BD4E-CB4CCA059FC4}" type="datetimeFigureOut">
               <a:rPr lang="en-US" smtClean="0"/>
-              <a:t>10/9/2026</a:t>
+              <a:t>1/27/13</a:t>
             </a:fld>
             <a:endParaRPr lang="en-US"/>
           </a:p>
@@ -1166,9 +1159,10 @@
           <a:lstStyle/>
           <a:p>
             <a:r>
-              <a:rPr lang="en-US"/>
+              <a:rPr lang="en-US" smtClean="0"/>
               <a:t>Click to edit Master title style</a:t>
             </a:r>
+            <a:endParaRPr lang="en-US"/>
           </a:p>
         </p:txBody>
       </p:sp>
@@ -1222,37 +1216,38 @@
           <a:p>
             <a:pPr lvl="0"/>
             <a:r>
-              <a:rPr lang="en-US"/>
+              <a:rPr lang="en-US" smtClean="0"/>
               <a:t>Click to edit Master text styles</a:t>
             </a:r>
           </a:p>
           <a:p>
             <a:pPr lvl="1"/>
             <a:r>
-              <a:rPr lang="en-US"/>
+              <a:rPr lang="en-US" smtClean="0"/>
               <a:t>Second level</a:t>
             </a:r>
           </a:p>
           <a:p>
             <a:pPr lvl="2"/>
             <a:r>
-              <a:rPr lang="en-US"/>
+              <a:rPr lang="en-US" smtClean="0"/>
               <a:t>Third level</a:t>
             </a:r>
           </a:p>
           <a:p>
             <a:pPr lvl="3"/>
             <a:r>
-              <a:rPr lang="en-US"/>
+              <a:rPr lang="en-US" smtClean="0"/>
               <a:t>Fourth level</a:t>
             </a:r>
           </a:p>
           <a:p>
             <a:pPr lvl="4"/>
             <a:r>
-              <a:rPr lang="en-US"/>
+              <a:rPr lang="en-US" smtClean="0"/>
               <a:t>Fifth level</a:t>
             </a:r>
+            <a:endParaRPr lang="en-US"/>
           </a:p>
         </p:txBody>
       </p:sp>
@@ -1306,37 +1301,38 @@
           <a:p>
             <a:pPr lvl="0"/>
             <a:r>
-              <a:rPr lang="en-US"/>
+              <a:rPr lang="en-US" smtClean="0"/>
               <a:t>Click to edit Master text styles</a:t>
             </a:r>
           </a:p>
           <a:p>
             <a:pPr lvl="1"/>
             <a:r>
-              <a:rPr lang="en-US"/>
+              <a:rPr lang="en-US" smtClean="0"/>
               <a:t>Second level</a:t>
             </a:r>
           </a:p>
           <a:p>
             <a:pPr lvl="2"/>
             <a:r>
-              <a:rPr lang="en-US"/>
+              <a:rPr lang="en-US" smtClean="0"/>
               <a:t>Third level</a:t>
             </a:r>
           </a:p>
           <a:p>
             <a:pPr lvl="3"/>
             <a:r>
-              <a:rPr lang="en-US"/>
+              <a:rPr lang="en-US" smtClean="0"/>
               <a:t>Fourth level</a:t>
             </a:r>
           </a:p>
           <a:p>
             <a:pPr lvl="4"/>
             <a:r>
-              <a:rPr lang="en-US"/>
+              <a:rPr lang="en-US" smtClean="0"/>
               <a:t>Fifth level</a:t>
             </a:r>
+            <a:endParaRPr lang="en-US"/>
           </a:p>
         </p:txBody>
       </p:sp>
@@ -1357,7 +1353,7 @@
           <a:p>
             <a:fld id="{5BCAD085-E8A6-8845-BD4E-CB4CCA059FC4}" type="datetimeFigureOut">
               <a:rPr lang="en-US" smtClean="0"/>
-              <a:t>10/9/2026</a:t>
+              <a:t>1/27/13</a:t>
             </a:fld>
             <a:endParaRPr lang="en-US"/>
           </a:p>
@@ -1455,9 +1451,10 @@
           </a:lstStyle>
           <a:p>
             <a:r>
-              <a:rPr lang="en-US"/>
+              <a:rPr lang="en-US" smtClean="0"/>
               <a:t>Click to edit Master title style</a:t>
             </a:r>
+            <a:endParaRPr lang="en-US"/>
           </a:p>
         </p:txBody>
       </p:sp>
@@ -1520,7 +1517,7 @@
           <a:p>
             <a:pPr lvl="0"/>
             <a:r>
-              <a:rPr lang="en-US"/>
+              <a:rPr lang="en-US" smtClean="0"/>
               <a:t>Click to edit Master text styles</a:t>
             </a:r>
           </a:p>
@@ -1576,37 +1573,38 @@
           <a:p>
             <a:pPr lvl="0"/>
             <a:r>
-              <a:rPr lang="en-US"/>
+              <a:rPr lang="en-US" smtClean="0"/>
               <a:t>Click to edit Master text styles</a:t>
             </a:r>
           </a:p>
           <a:p>
             <a:pPr lvl="1"/>
             <a:r>
-              <a:rPr lang="en-US"/>
+              <a:rPr lang="en-US" smtClean="0"/>
               <a:t>Second level</a:t>
             </a:r>
           </a:p>
           <a:p>
             <a:pPr lvl="2"/>
             <a:r>
-              <a:rPr lang="en-US"/>
+              <a:rPr lang="en-US" smtClean="0"/>
               <a:t>Third level</a:t>
             </a:r>
           </a:p>
           <a:p>
             <a:pPr lvl="3"/>
             <a:r>
-              <a:rPr lang="en-US"/>
+              <a:rPr lang="en-US" smtClean="0"/>
               <a:t>Fourth level</a:t>
             </a:r>
           </a:p>
           <a:p>
             <a:pPr lvl="4"/>
             <a:r>
-              <a:rPr lang="en-US"/>
+              <a:rPr lang="en-US" smtClean="0"/>
               <a:t>Fifth level</a:t>
             </a:r>
+            <a:endParaRPr lang="en-US"/>
           </a:p>
         </p:txBody>
       </p:sp>
@@ -1669,7 +1667,7 @@
           <a:p>
             <a:pPr lvl="0"/>
             <a:r>
-              <a:rPr lang="en-US"/>
+              <a:rPr lang="en-US" smtClean="0"/>
               <a:t>Click to edit Master text styles</a:t>
             </a:r>
           </a:p>
@@ -1725,37 +1723,38 @@
           <a:p>
             <a:pPr lvl="0"/>
             <a:r>
-              <a:rPr lang="en-US"/>
+              <a:rPr lang="en-US" smtClean="0"/>
               <a:t>Click to edit Master text styles</a:t>
             </a:r>
           </a:p>
           <a:p>
             <a:pPr lvl="1"/>
             <a:r>
-              <a:rPr lang="en-US"/>
+              <a:rPr lang="en-US" smtClean="0"/>
               <a:t>Second level</a:t>
             </a:r>
           </a:p>
           <a:p>
             <a:pPr lvl="2"/>
             <a:r>
-              <a:rPr lang="en-US"/>
+              <a:rPr lang="en-US" smtClean="0"/>
               <a:t>Third level</a:t>
             </a:r>
           </a:p>
           <a:p>
             <a:pPr lvl="3"/>
             <a:r>
-              <a:rPr lang="en-US"/>
+              <a:rPr lang="en-US" smtClean="0"/>
               <a:t>Fourth level</a:t>
             </a:r>
           </a:p>
           <a:p>
             <a:pPr lvl="4"/>
             <a:r>
-              <a:rPr lang="en-US"/>
+              <a:rPr lang="en-US" smtClean="0"/>
               <a:t>Fifth level</a:t>
             </a:r>
+            <a:endParaRPr lang="en-US"/>
           </a:p>
         </p:txBody>
       </p:sp>
@@ -1776,7 +1775,7 @@
           <a:p>
             <a:fld id="{5BCAD085-E8A6-8845-BD4E-CB4CCA059FC4}" type="datetimeFigureOut">
               <a:rPr lang="en-US" smtClean="0"/>
-              <a:t>10/9/2026</a:t>
+              <a:t>1/27/13</a:t>
             </a:fld>
             <a:endParaRPr lang="en-US"/>
           </a:p>
@@ -1870,9 +1869,10 @@
           <a:lstStyle/>
           <a:p>
             <a:r>
-              <a:rPr lang="en-US"/>
+              <a:rPr lang="en-US" smtClean="0"/>
               <a:t>Click to edit Master title style</a:t>
             </a:r>
+            <a:endParaRPr lang="en-US"/>
           </a:p>
         </p:txBody>
       </p:sp>
@@ -1893,7 +1893,7 @@
           <a:p>
             <a:fld id="{5BCAD085-E8A6-8845-BD4E-CB4CCA059FC4}" type="datetimeFigureOut">
               <a:rPr lang="en-US" smtClean="0"/>
-              <a:t>10/9/2026</a:t>
+              <a:t>1/27/13</a:t>
             </a:fld>
             <a:endParaRPr lang="en-US"/>
           </a:p>
@@ -1988,7 +1988,7 @@
           <a:p>
             <a:fld id="{5BCAD085-E8A6-8845-BD4E-CB4CCA059FC4}" type="datetimeFigureOut">
               <a:rPr lang="en-US" smtClean="0"/>
-              <a:t>10/9/2026</a:t>
+              <a:t>1/27/13</a:t>
             </a:fld>
             <a:endParaRPr lang="en-US"/>
           </a:p>
@@ -2091,9 +2091,10 @@
           </a:lstStyle>
           <a:p>
             <a:r>
-              <a:rPr lang="en-US"/>
+              <a:rPr lang="en-US" smtClean="0"/>
               <a:t>Click to edit Master title style</a:t>
             </a:r>
+            <a:endParaRPr lang="en-US"/>
           </a:p>
         </p:txBody>
       </p:sp>
@@ -2147,37 +2148,38 @@
           <a:p>
             <a:pPr lvl="0"/>
             <a:r>
-              <a:rPr lang="en-US"/>
+              <a:rPr lang="en-US" smtClean="0"/>
               <a:t>Click to edit Master text styles</a:t>
             </a:r>
           </a:p>
           <a:p>
             <a:pPr lvl="1"/>
             <a:r>
-              <a:rPr lang="en-US"/>
+              <a:rPr lang="en-US" smtClean="0"/>
               <a:t>Second level</a:t>
             </a:r>
           </a:p>
           <a:p>
             <a:pPr lvl="2"/>
             <a:r>
-              <a:rPr lang="en-US"/>
+              <a:rPr lang="en-US" smtClean="0"/>
               <a:t>Third level</a:t>
             </a:r>
           </a:p>
           <a:p>
             <a:pPr lvl="3"/>
             <a:r>
-              <a:rPr lang="en-US"/>
+              <a:rPr lang="en-US" smtClean="0"/>
               <a:t>Fourth level</a:t>
             </a:r>
           </a:p>
           <a:p>
             <a:pPr lvl="4"/>
             <a:r>
-              <a:rPr lang="en-US"/>
+              <a:rPr lang="en-US" smtClean="0"/>
               <a:t>Fifth level</a:t>
             </a:r>
+            <a:endParaRPr lang="en-US"/>
           </a:p>
         </p:txBody>
       </p:sp>
@@ -2240,7 +2242,7 @@
           <a:p>
             <a:pPr lvl="0"/>
             <a:r>
-              <a:rPr lang="en-US"/>
+              <a:rPr lang="en-US" smtClean="0"/>
               <a:t>Click to edit Master text styles</a:t>
             </a:r>
           </a:p>
@@ -2263,7 +2265,7 @@
           <a:p>
             <a:fld id="{5BCAD085-E8A6-8845-BD4E-CB4CCA059FC4}" type="datetimeFigureOut">
               <a:rPr lang="en-US" smtClean="0"/>
-              <a:t>10/9/2026</a:t>
+              <a:t>1/27/13</a:t>
             </a:fld>
             <a:endParaRPr lang="en-US"/>
           </a:p>
@@ -2366,9 +2368,10 @@
           </a:lstStyle>
           <a:p>
             <a:r>
-              <a:rPr lang="en-US"/>
+              <a:rPr lang="en-US" smtClean="0"/>
               <a:t>Click to edit Master title style</a:t>
             </a:r>
+            <a:endParaRPr lang="en-US"/>
           </a:p>
         </p:txBody>
       </p:sp>
@@ -2492,7 +2495,7 @@
           <a:p>
             <a:pPr lvl="0"/>
             <a:r>
-              <a:rPr lang="en-US"/>
+              <a:rPr lang="en-US" smtClean="0"/>
               <a:t>Click to edit Master text styles</a:t>
             </a:r>
           </a:p>
@@ -2515,7 +2518,7 @@
           <a:p>
             <a:fld id="{5BCAD085-E8A6-8845-BD4E-CB4CCA059FC4}" type="datetimeFigureOut">
               <a:rPr lang="en-US" smtClean="0"/>
-              <a:t>10/9/2026</a:t>
+              <a:t>1/27/13</a:t>
             </a:fld>
             <a:endParaRPr lang="en-US"/>
           </a:p>
@@ -2624,9 +2627,10 @@
           <a:lstStyle/>
           <a:p>
             <a:r>
-              <a:rPr lang="en-US"/>
+              <a:rPr lang="en-US" smtClean="0"/>
               <a:t>Click to edit Master title style</a:t>
             </a:r>
+            <a:endParaRPr lang="en-US"/>
           </a:p>
         </p:txBody>
       </p:sp>
@@ -2657,37 +2661,38 @@
           <a:p>
             <a:pPr lvl="0"/>
             <a:r>
-              <a:rPr lang="en-US"/>
+              <a:rPr lang="en-US" smtClean="0"/>
               <a:t>Click to edit Master text styles</a:t>
             </a:r>
           </a:p>
           <a:p>
             <a:pPr lvl="1"/>
             <a:r>
-              <a:rPr lang="en-US"/>
+              <a:rPr lang="en-US" smtClean="0"/>
               <a:t>Second level</a:t>
             </a:r>
           </a:p>
           <a:p>
             <a:pPr lvl="2"/>
             <a:r>
-              <a:rPr lang="en-US"/>
+              <a:rPr lang="en-US" smtClean="0"/>
               <a:t>Third level</a:t>
             </a:r>
           </a:p>
           <a:p>
             <a:pPr lvl="3"/>
             <a:r>
-              <a:rPr lang="en-US"/>
+              <a:rPr lang="en-US" smtClean="0"/>
               <a:t>Fourth level</a:t>
             </a:r>
           </a:p>
           <a:p>
             <a:pPr lvl="4"/>
             <a:r>
-              <a:rPr lang="en-US"/>
+              <a:rPr lang="en-US" smtClean="0"/>
               <a:t>Fifth level</a:t>
             </a:r>
+            <a:endParaRPr lang="en-US"/>
           </a:p>
         </p:txBody>
       </p:sp>
@@ -2726,7 +2731,7 @@
           <a:p>
             <a:fld id="{5BCAD085-E8A6-8845-BD4E-CB4CCA059FC4}" type="datetimeFigureOut">
               <a:rPr lang="en-US" smtClean="0"/>
-              <a:t>10/9/2026</a:t>
+              <a:t>1/27/13</a:t>
             </a:fld>
             <a:endParaRPr lang="en-US"/>
           </a:p>
@@ -3085,7 +3090,7 @@
 </file>
 
 <file path=ppt/slides/slide1.xml><?xml version="1.0" encoding="utf-8"?>
-<p:sld xmlns:a="http://schemas.openxmlformats.org/drawingml/2006/main" xmlns:r="http://schemas.openxmlformats.org/officeDocument/2006/relationships" xmlns:p="http://schemas.openxmlformats.org/presentationml/2006/main">
+<p:sld xmlns:a="http://schemas.openxmlformats.org/drawingml/2006/main" xmlns:p="http://schemas.openxmlformats.org/presentationml/2006/main" xmlns:r="http://schemas.openxmlformats.org/officeDocument/2006/relationships">
   <p:cSld>
     <p:spTree>
       <p:nvGrpSpPr>
@@ -3093,14 +3098,7 @@
         <p:cNvGrpSpPr/>
         <p:nvPr/>
       </p:nvGrpSpPr>
-      <p:grpSpPr>
-        <a:xfrm>
-          <a:off x="0" y="0"/>
-          <a:ext cx="0" cy="0"/>
-          <a:chOff x="0" y="0"/>
-          <a:chExt cx="0" cy="0"/>
-        </a:xfrm>
-      </p:grpSpPr>
+      <p:grpSpPr/>
       <p:sp>
         <p:nvSpPr>
           <p:cNvPr id="2" name="Rectangle 1"/>
@@ -3143,7 +3141,6 @@
           <a:lstStyle/>
           <a:p>
             <a:pPr algn="ctr"/>
-            <a:endParaRPr/>
           </a:p>
         </p:txBody>
       </p:sp>
@@ -3189,7 +3186,6 @@
           <a:lstStyle/>
           <a:p>
             <a:pPr algn="ctr"/>
-            <a:endParaRPr/>
           </a:p>
         </p:txBody>
       </p:sp>
@@ -3334,7 +3330,6 @@
           <a:lstStyle/>
           <a:p>
             <a:pPr algn="ctr"/>
-            <a:endParaRPr/>
           </a:p>
         </p:txBody>
       </p:sp>
@@ -3383,7 +3378,7 @@
               </a:defRPr>
             </a:pPr>
             <a:r>
-              <a:t>Lead &amp; Core Architect</a:t>
+              <a:t>Lead Systems Architect</a:t>
             </a:r>
           </a:p>
           <a:p>
@@ -3398,7 +3393,7 @@
               </a:defRPr>
             </a:pPr>
             <a:r>
-              <a:t>Autonomous Multi-Agent Systems &amp; HiGHS SCED Formulation</a:t>
+              <a:t>Autonomous Multi-Agent Architecture &amp; HiGHS SCED LP Solver</a:t>
             </a:r>
           </a:p>
         </p:txBody>
@@ -3445,7 +3440,6 @@
           <a:lstStyle/>
           <a:p>
             <a:pPr algn="ctr"/>
-            <a:endParaRPr/>
           </a:p>
         </p:txBody>
       </p:sp>
@@ -3479,8 +3473,7 @@
               </a:defRPr>
             </a:pPr>
             <a:r>
-              <a:rPr dirty="0"/>
-              <a:t>👤 X</a:t>
+              <a:t>👤 B Iniyavan</a:t>
             </a:r>
           </a:p>
           <a:p>
@@ -3495,8 +3488,7 @@
               </a:defRPr>
             </a:pPr>
             <a:r>
-              <a:rPr dirty="0"/>
-              <a:t>Co-Lead &amp; Systems Engineer</a:t>
+              <a:t>Systems Co-Lead</a:t>
             </a:r>
           </a:p>
           <a:p>
@@ -3511,8 +3503,7 @@
               </a:defRPr>
             </a:pPr>
             <a:r>
-              <a:rPr dirty="0"/>
-              <a:t>Perception Pipeline &amp; Multimodal Radar Computer Vision</a:t>
+              <a:t>SCADA Protocol Bus (IEC 61850 / DNP3) &amp; Real-Time Orchestration</a:t>
             </a:r>
           </a:p>
         </p:txBody>
@@ -3559,7 +3550,6 @@
           <a:lstStyle/>
           <a:p>
             <a:pPr algn="ctr"/>
-            <a:endParaRPr/>
           </a:p>
         </p:txBody>
       </p:sp>
@@ -3572,7 +3562,7 @@
         <p:spPr>
           <a:xfrm>
             <a:off x="6263640" y="4434840"/>
-            <a:ext cx="2020824" cy="772006"/>
+            <a:ext cx="2020824" cy="1280160"/>
           </a:xfrm>
           <a:prstGeom prst="rect">
             <a:avLst/>
@@ -3588,13 +3578,12 @@
             <a:pPr>
               <a:defRPr sz="1300" b="1">
                 <a:solidFill>
-                  <a:srgbClr val="059669"/>
-                </a:solidFill>
-              </a:defRPr>
-            </a:pPr>
-            <a:r>
-              <a:rPr lang="en-IN" dirty="0"/>
-              <a:t>👤 X</a:t>
+                  <a:srgbClr val="7C3AED"/>
+                </a:solidFill>
+              </a:defRPr>
+            </a:pPr>
+            <a:r>
+              <a:t>👤 Nishi Verma</a:t>
             </a:r>
           </a:p>
           <a:p>
@@ -3609,8 +3598,7 @@
               </a:defRPr>
             </a:pPr>
             <a:r>
-              <a:rPr lang="en-IN" dirty="0"/>
-              <a:t>Co-Lead &amp; Systems Engineer</a:t>
+              <a:t>Power Optimization Lead</a:t>
             </a:r>
           </a:p>
           <a:p>
@@ -3625,8 +3613,7 @@
               </a:defRPr>
             </a:pPr>
             <a:r>
-              <a:rPr lang="en-IN" dirty="0"/>
-              <a:t>Perception Pipeline &amp; Multimodal Radar Computer Vision</a:t>
+              <a:t>Wholesale Electricity Market Arbitrage &amp; Kirchhoff Balancer</a:t>
             </a:r>
           </a:p>
         </p:txBody>
@@ -3673,7 +3660,6 @@
           <a:lstStyle/>
           <a:p>
             <a:pPr algn="ctr"/>
-            <a:endParaRPr/>
           </a:p>
         </p:txBody>
       </p:sp>
@@ -3686,7 +3672,7 @@
         <p:spPr>
           <a:xfrm>
             <a:off x="8723376" y="4434840"/>
-            <a:ext cx="2020824" cy="772006"/>
+            <a:ext cx="2020824" cy="1280160"/>
           </a:xfrm>
           <a:prstGeom prst="rect">
             <a:avLst/>
@@ -3702,13 +3688,12 @@
             <a:pPr>
               <a:defRPr sz="1300" b="1">
                 <a:solidFill>
-                  <a:srgbClr val="059669"/>
-                </a:solidFill>
-              </a:defRPr>
-            </a:pPr>
-            <a:r>
-              <a:rPr lang="en-IN" dirty="0"/>
-              <a:t>👤 X</a:t>
+                  <a:srgbClr val="D97706"/>
+                </a:solidFill>
+              </a:defRPr>
+            </a:pPr>
+            <a:r>
+              <a:t>👤 Pasupulati Siva Puja</a:t>
             </a:r>
           </a:p>
           <a:p>
@@ -3723,8 +3708,7 @@
               </a:defRPr>
             </a:pPr>
             <a:r>
-              <a:rPr lang="en-IN" dirty="0"/>
-              <a:t>Co-Lead &amp; Systems Engineer</a:t>
+              <a:t>Cyber-Physical AI Lead</a:t>
             </a:r>
           </a:p>
           <a:p>
@@ -3739,8 +3723,7 @@
               </a:defRPr>
             </a:pPr>
             <a:r>
-              <a:rPr lang="en-IN" dirty="0"/>
-              <a:t>Perception Pipeline &amp; Multimodal Radar Computer Vision</a:t>
+              <a:t>Doppler Radar CV Vision Ingestion &amp; Gemini Regulatory Audit AI</a:t>
             </a:r>
           </a:p>
         </p:txBody>
@@ -3754,7 +3737,7 @@
 </file>
 
 <file path=ppt/slides/slide10.xml><?xml version="1.0" encoding="utf-8"?>
-<p:sld xmlns:a="http://schemas.openxmlformats.org/drawingml/2006/main" xmlns:r="http://schemas.openxmlformats.org/officeDocument/2006/relationships" xmlns:p="http://schemas.openxmlformats.org/presentationml/2006/main">
+<p:sld xmlns:a="http://schemas.openxmlformats.org/drawingml/2006/main" xmlns:p="http://schemas.openxmlformats.org/presentationml/2006/main" xmlns:r="http://schemas.openxmlformats.org/officeDocument/2006/relationships">
   <p:cSld>
     <p:spTree>
       <p:nvGrpSpPr>
@@ -3762,14 +3745,7 @@
         <p:cNvGrpSpPr/>
         <p:nvPr/>
       </p:nvGrpSpPr>
-      <p:grpSpPr>
-        <a:xfrm>
-          <a:off x="0" y="0"/>
-          <a:ext cx="0" cy="0"/>
-          <a:chOff x="0" y="0"/>
-          <a:chExt cx="0" cy="0"/>
-        </a:xfrm>
-      </p:grpSpPr>
+      <p:grpSpPr/>
       <p:sp>
         <p:nvSpPr>
           <p:cNvPr id="2" name="Rectangle 1"/>
@@ -3812,7 +3788,6 @@
           <a:lstStyle/>
           <a:p>
             <a:pPr algn="ctr"/>
-            <a:endParaRPr/>
           </a:p>
         </p:txBody>
       </p:sp>
@@ -3833,7 +3808,7 @@
           <a:noFill/>
         </p:spPr>
         <p:txBody>
-          <a:bodyPr wrap="square" lIns="0" tIns="0" rIns="0" bIns="0">
+          <a:bodyPr wrap="square" lIns="0" rIns="0" tIns="0" bIns="0">
             <a:spAutoFit/>
           </a:bodyPr>
           <a:lstStyle/>
@@ -3869,7 +3844,7 @@
           <a:noFill/>
         </p:spPr>
         <p:txBody>
-          <a:bodyPr wrap="square" lIns="0" tIns="0" rIns="0" bIns="0">
+          <a:bodyPr wrap="square" lIns="0" rIns="0" tIns="0" bIns="0">
             <a:spAutoFit/>
           </a:bodyPr>
           <a:lstStyle/>
@@ -3930,7 +3905,6 @@
           <a:lstStyle/>
           <a:p>
             <a:pPr algn="ctr"/>
-            <a:endParaRPr/>
           </a:p>
         </p:txBody>
       </p:sp>
@@ -4080,7 +4054,6 @@
           <a:lstStyle/>
           <a:p>
             <a:pPr algn="ctr"/>
-            <a:endParaRPr/>
           </a:p>
         </p:txBody>
       </p:sp>
@@ -4203,7 +4176,7 @@
 </file>
 
 <file path=ppt/slides/slide11.xml><?xml version="1.0" encoding="utf-8"?>
-<p:sld xmlns:a="http://schemas.openxmlformats.org/drawingml/2006/main" xmlns:r="http://schemas.openxmlformats.org/officeDocument/2006/relationships" xmlns:p="http://schemas.openxmlformats.org/presentationml/2006/main">
+<p:sld xmlns:a="http://schemas.openxmlformats.org/drawingml/2006/main" xmlns:p="http://schemas.openxmlformats.org/presentationml/2006/main" xmlns:r="http://schemas.openxmlformats.org/officeDocument/2006/relationships">
   <p:cSld>
     <p:spTree>
       <p:nvGrpSpPr>
@@ -4211,14 +4184,7 @@
         <p:cNvGrpSpPr/>
         <p:nvPr/>
       </p:nvGrpSpPr>
-      <p:grpSpPr>
-        <a:xfrm>
-          <a:off x="0" y="0"/>
-          <a:ext cx="0" cy="0"/>
-          <a:chOff x="0" y="0"/>
-          <a:chExt cx="0" cy="0"/>
-        </a:xfrm>
-      </p:grpSpPr>
+      <p:grpSpPr/>
       <p:sp>
         <p:nvSpPr>
           <p:cNvPr id="2" name="Rectangle 1"/>
@@ -4261,7 +4227,6 @@
           <a:lstStyle/>
           <a:p>
             <a:pPr algn="ctr"/>
-            <a:endParaRPr/>
           </a:p>
         </p:txBody>
       </p:sp>
@@ -4282,7 +4247,7 @@
           <a:noFill/>
         </p:spPr>
         <p:txBody>
-          <a:bodyPr wrap="square" lIns="0" tIns="0" rIns="0" bIns="0">
+          <a:bodyPr wrap="square" lIns="0" rIns="0" tIns="0" bIns="0">
             <a:spAutoFit/>
           </a:bodyPr>
           <a:lstStyle/>
@@ -4318,7 +4283,7 @@
           <a:noFill/>
         </p:spPr>
         <p:txBody>
-          <a:bodyPr wrap="square" lIns="0" tIns="0" rIns="0" bIns="0">
+          <a:bodyPr wrap="square" lIns="0" rIns="0" tIns="0" bIns="0">
             <a:spAutoFit/>
           </a:bodyPr>
           <a:lstStyle/>
@@ -4379,7 +4344,6 @@
           <a:lstStyle/>
           <a:p>
             <a:pPr algn="ctr"/>
-            <a:endParaRPr/>
           </a:p>
         </p:txBody>
       </p:sp>
@@ -4568,7 +4532,6 @@
           <a:lstStyle/>
           <a:p>
             <a:pPr algn="ctr"/>
-            <a:endParaRPr/>
           </a:p>
         </p:txBody>
       </p:sp>
@@ -4691,7 +4654,7 @@
 </file>
 
 <file path=ppt/slides/slide12.xml><?xml version="1.0" encoding="utf-8"?>
-<p:sld xmlns:a="http://schemas.openxmlformats.org/drawingml/2006/main" xmlns:r="http://schemas.openxmlformats.org/officeDocument/2006/relationships" xmlns:p="http://schemas.openxmlformats.org/presentationml/2006/main">
+<p:sld xmlns:a="http://schemas.openxmlformats.org/drawingml/2006/main" xmlns:p="http://schemas.openxmlformats.org/presentationml/2006/main" xmlns:r="http://schemas.openxmlformats.org/officeDocument/2006/relationships">
   <p:cSld>
     <p:spTree>
       <p:nvGrpSpPr>
@@ -4699,14 +4662,7 @@
         <p:cNvGrpSpPr/>
         <p:nvPr/>
       </p:nvGrpSpPr>
-      <p:grpSpPr>
-        <a:xfrm>
-          <a:off x="0" y="0"/>
-          <a:ext cx="0" cy="0"/>
-          <a:chOff x="0" y="0"/>
-          <a:chExt cx="0" cy="0"/>
-        </a:xfrm>
-      </p:grpSpPr>
+      <p:grpSpPr/>
       <p:sp>
         <p:nvSpPr>
           <p:cNvPr id="2" name="Rectangle 1"/>
@@ -4749,7 +4705,6 @@
           <a:lstStyle/>
           <a:p>
             <a:pPr algn="ctr"/>
-            <a:endParaRPr/>
           </a:p>
         </p:txBody>
       </p:sp>
@@ -4795,7 +4750,6 @@
           <a:lstStyle/>
           <a:p>
             <a:pPr algn="ctr"/>
-            <a:endParaRPr/>
           </a:p>
         </p:txBody>
       </p:sp>
@@ -4808,7 +4762,7 @@
         <p:spPr>
           <a:xfrm>
             <a:off x="1463040" y="1188720"/>
-            <a:ext cx="9265615" cy="2641749"/>
+            <a:ext cx="9265615" cy="4480560"/>
           </a:xfrm>
           <a:prstGeom prst="rect">
             <a:avLst/>
@@ -4829,7 +4783,6 @@
               </a:defRPr>
             </a:pPr>
             <a:r>
-              <a:rPr dirty="0"/>
               <a:t>🚀 PRODUCTION-READY CYBER-PHYSICAL DEPLOYMENT 🚀</a:t>
             </a:r>
           </a:p>
@@ -4845,7 +4798,6 @@
               </a:defRPr>
             </a:pPr>
             <a:r>
-              <a:rPr dirty="0"/>
               <a:t>Thank You / Q&amp;A</a:t>
             </a:r>
           </a:p>
@@ -4861,12 +4813,7 @@
               </a:defRPr>
             </a:pPr>
             <a:r>
-              <a:rPr dirty="0" err="1"/>
-              <a:t>GridOS</a:t>
-            </a:r>
-            <a:r>
-              <a:rPr dirty="0"/>
-              <a:t>™: Setting the Gold Standard for Autonomous Renewable Microgrids</a:t>
+              <a:t>GridOS™: Setting the Gold Standard for Autonomous Renewable Microgrids</a:t>
             </a:r>
           </a:p>
           <a:p>
@@ -4881,14 +4828,10 @@
               </a:defRPr>
             </a:pPr>
             <a:r>
-              <a:rPr dirty="0"/>
               <a:t>• Live Console: http://localhost:8501  •  Automated Tests: 25/25 Passing (100%)</a:t>
             </a:r>
-            <a:br>
-              <a:rPr dirty="0"/>
-            </a:br>
-            <a:r>
-              <a:rPr dirty="0"/>
+            <a:br/>
+            <a:r>
               <a:t>• Deterministic Math: Exact Kirchhoff Conservation (|Δ| = 0.00 MW)  •  Audit Grade: A+ (98.4/100)</a:t>
             </a:r>
           </a:p>
@@ -4904,7 +4847,6 @@
               </a:defRPr>
             </a:pPr>
             <a:r>
-              <a:rPr dirty="0"/>
               <a:t>Core Engineering Team:</a:t>
             </a:r>
           </a:p>
@@ -4913,31 +4855,14 @@
               <a:spcBef>
                 <a:spcPts val="600"/>
               </a:spcBef>
-              <a:defRPr sz="1200" b="1">
+              <a:defRPr sz="1100" b="1">
                 <a:solidFill>
                   <a:srgbClr val="0F172A"/>
                 </a:solidFill>
               </a:defRPr>
             </a:pPr>
             <a:r>
-              <a:rPr dirty="0"/>
-              <a:t>ManojKumar P (Lead Architect)   |   X (Systems Co-Lead)   |   Y (</a:t>
-            </a:r>
-            <a:r>
-              <a:rPr lang="en-IN" dirty="0"/>
-              <a:t>Co-Lead</a:t>
-            </a:r>
-            <a:r>
-              <a:rPr dirty="0"/>
-              <a:t>)   |   Z (</a:t>
-            </a:r>
-            <a:r>
-              <a:rPr lang="en-IN" dirty="0"/>
-              <a:t>Co-Lead</a:t>
-            </a:r>
-            <a:r>
-              <a:rPr dirty="0"/>
-              <a:t>)</a:t>
+              <a:t>ManojKumar P (Lead Architect)   |   B Iniyavan (Systems Co-Lead)   |   Nishi Verma (Power Optimization)   |   Pasupulati Siva Puja (Cyber-Physical AI)</a:t>
             </a:r>
           </a:p>
         </p:txBody>
@@ -4951,7 +4876,7 @@
 </file>
 
 <file path=ppt/slides/slide2.xml><?xml version="1.0" encoding="utf-8"?>
-<p:sld xmlns:a="http://schemas.openxmlformats.org/drawingml/2006/main" xmlns:r="http://schemas.openxmlformats.org/officeDocument/2006/relationships" xmlns:p="http://schemas.openxmlformats.org/presentationml/2006/main">
+<p:sld xmlns:a="http://schemas.openxmlformats.org/drawingml/2006/main" xmlns:p="http://schemas.openxmlformats.org/presentationml/2006/main" xmlns:r="http://schemas.openxmlformats.org/officeDocument/2006/relationships">
   <p:cSld>
     <p:spTree>
       <p:nvGrpSpPr>
@@ -4959,14 +4884,7 @@
         <p:cNvGrpSpPr/>
         <p:nvPr/>
       </p:nvGrpSpPr>
-      <p:grpSpPr>
-        <a:xfrm>
-          <a:off x="0" y="0"/>
-          <a:ext cx="0" cy="0"/>
-          <a:chOff x="0" y="0"/>
-          <a:chExt cx="0" cy="0"/>
-        </a:xfrm>
-      </p:grpSpPr>
+      <p:grpSpPr/>
       <p:sp>
         <p:nvSpPr>
           <p:cNvPr id="2" name="Rectangle 1"/>
@@ -5009,7 +4927,6 @@
           <a:lstStyle/>
           <a:p>
             <a:pPr algn="ctr"/>
-            <a:endParaRPr/>
           </a:p>
         </p:txBody>
       </p:sp>
@@ -5030,7 +4947,7 @@
           <a:noFill/>
         </p:spPr>
         <p:txBody>
-          <a:bodyPr wrap="square" lIns="0" tIns="0" rIns="0" bIns="0">
+          <a:bodyPr wrap="square" lIns="0" rIns="0" tIns="0" bIns="0">
             <a:spAutoFit/>
           </a:bodyPr>
           <a:lstStyle/>
@@ -5066,7 +4983,7 @@
           <a:noFill/>
         </p:spPr>
         <p:txBody>
-          <a:bodyPr wrap="square" lIns="0" tIns="0" rIns="0" bIns="0">
+          <a:bodyPr wrap="square" lIns="0" rIns="0" tIns="0" bIns="0">
             <a:spAutoFit/>
           </a:bodyPr>
           <a:lstStyle/>
@@ -5127,7 +5044,6 @@
           <a:lstStyle/>
           <a:p>
             <a:pPr algn="ctr"/>
-            <a:endParaRPr/>
           </a:p>
         </p:txBody>
       </p:sp>
@@ -5253,7 +5169,6 @@
           <a:lstStyle/>
           <a:p>
             <a:pPr algn="ctr"/>
-            <a:endParaRPr/>
           </a:p>
         </p:txBody>
       </p:sp>
@@ -5439,7 +5354,6 @@
           <a:lstStyle/>
           <a:p>
             <a:pPr algn="ctr"/>
-            <a:endParaRPr/>
           </a:p>
         </p:txBody>
       </p:sp>
@@ -5532,7 +5446,7 @@
 </file>
 
 <file path=ppt/slides/slide3.xml><?xml version="1.0" encoding="utf-8"?>
-<p:sld xmlns:a="http://schemas.openxmlformats.org/drawingml/2006/main" xmlns:r="http://schemas.openxmlformats.org/officeDocument/2006/relationships" xmlns:p="http://schemas.openxmlformats.org/presentationml/2006/main">
+<p:sld xmlns:a="http://schemas.openxmlformats.org/drawingml/2006/main" xmlns:p="http://schemas.openxmlformats.org/presentationml/2006/main" xmlns:r="http://schemas.openxmlformats.org/officeDocument/2006/relationships">
   <p:cSld>
     <p:spTree>
       <p:nvGrpSpPr>
@@ -5540,14 +5454,7 @@
         <p:cNvGrpSpPr/>
         <p:nvPr/>
       </p:nvGrpSpPr>
-      <p:grpSpPr>
-        <a:xfrm>
-          <a:off x="0" y="0"/>
-          <a:ext cx="0" cy="0"/>
-          <a:chOff x="0" y="0"/>
-          <a:chExt cx="0" cy="0"/>
-        </a:xfrm>
-      </p:grpSpPr>
+      <p:grpSpPr/>
       <p:sp>
         <p:nvSpPr>
           <p:cNvPr id="2" name="Rectangle 1"/>
@@ -5590,7 +5497,6 @@
           <a:lstStyle/>
           <a:p>
             <a:pPr algn="ctr"/>
-            <a:endParaRPr/>
           </a:p>
         </p:txBody>
       </p:sp>
@@ -5611,7 +5517,7 @@
           <a:noFill/>
         </p:spPr>
         <p:txBody>
-          <a:bodyPr wrap="square" lIns="0" tIns="0" rIns="0" bIns="0">
+          <a:bodyPr wrap="square" lIns="0" rIns="0" tIns="0" bIns="0">
             <a:spAutoFit/>
           </a:bodyPr>
           <a:lstStyle/>
@@ -5647,7 +5553,7 @@
           <a:noFill/>
         </p:spPr>
         <p:txBody>
-          <a:bodyPr wrap="square" lIns="0" tIns="0" rIns="0" bIns="0">
+          <a:bodyPr wrap="square" lIns="0" rIns="0" tIns="0" bIns="0">
             <a:spAutoFit/>
           </a:bodyPr>
           <a:lstStyle/>
@@ -5708,7 +5614,6 @@
           <a:lstStyle/>
           <a:p>
             <a:pPr algn="ctr"/>
-            <a:endParaRPr/>
           </a:p>
         </p:txBody>
       </p:sp>
@@ -5808,7 +5713,6 @@
           <a:lstStyle/>
           <a:p>
             <a:pPr algn="ctr"/>
-            <a:endParaRPr/>
           </a:p>
         </p:txBody>
       </p:sp>
@@ -5912,7 +5816,6 @@
           <a:lstStyle/>
           <a:p>
             <a:pPr algn="ctr"/>
-            <a:endParaRPr/>
           </a:p>
         </p:txBody>
       </p:sp>
@@ -5979,7 +5882,7 @@
 </file>
 
 <file path=ppt/slides/slide4.xml><?xml version="1.0" encoding="utf-8"?>
-<p:sld xmlns:a="http://schemas.openxmlformats.org/drawingml/2006/main" xmlns:r="http://schemas.openxmlformats.org/officeDocument/2006/relationships" xmlns:p="http://schemas.openxmlformats.org/presentationml/2006/main">
+<p:sld xmlns:a="http://schemas.openxmlformats.org/drawingml/2006/main" xmlns:p="http://schemas.openxmlformats.org/presentationml/2006/main" xmlns:r="http://schemas.openxmlformats.org/officeDocument/2006/relationships">
   <p:cSld>
     <p:spTree>
       <p:nvGrpSpPr>
@@ -5987,14 +5890,7 @@
         <p:cNvGrpSpPr/>
         <p:nvPr/>
       </p:nvGrpSpPr>
-      <p:grpSpPr>
-        <a:xfrm>
-          <a:off x="0" y="0"/>
-          <a:ext cx="0" cy="0"/>
-          <a:chOff x="0" y="0"/>
-          <a:chExt cx="0" cy="0"/>
-        </a:xfrm>
-      </p:grpSpPr>
+      <p:grpSpPr/>
       <p:sp>
         <p:nvSpPr>
           <p:cNvPr id="2" name="Rectangle 1"/>
@@ -6037,7 +5933,6 @@
           <a:lstStyle/>
           <a:p>
             <a:pPr algn="ctr"/>
-            <a:endParaRPr/>
           </a:p>
         </p:txBody>
       </p:sp>
@@ -6058,7 +5953,7 @@
           <a:noFill/>
         </p:spPr>
         <p:txBody>
-          <a:bodyPr wrap="square" lIns="0" tIns="0" rIns="0" bIns="0">
+          <a:bodyPr wrap="square" lIns="0" rIns="0" tIns="0" bIns="0">
             <a:spAutoFit/>
           </a:bodyPr>
           <a:lstStyle/>
@@ -6094,7 +5989,7 @@
           <a:noFill/>
         </p:spPr>
         <p:txBody>
-          <a:bodyPr wrap="square" lIns="0" tIns="0" rIns="0" bIns="0">
+          <a:bodyPr wrap="square" lIns="0" rIns="0" tIns="0" bIns="0">
             <a:spAutoFit/>
           </a:bodyPr>
           <a:lstStyle/>
@@ -6155,7 +6050,6 @@
           <a:lstStyle/>
           <a:p>
             <a:pPr algn="ctr"/>
-            <a:endParaRPr/>
           </a:p>
         </p:txBody>
       </p:sp>
@@ -6311,7 +6205,6 @@
           <a:lstStyle/>
           <a:p>
             <a:pPr algn="ctr"/>
-            <a:endParaRPr/>
           </a:p>
         </p:txBody>
       </p:sp>
@@ -6434,7 +6327,7 @@
 </file>
 
 <file path=ppt/slides/slide5.xml><?xml version="1.0" encoding="utf-8"?>
-<p:sld xmlns:a="http://schemas.openxmlformats.org/drawingml/2006/main" xmlns:r="http://schemas.openxmlformats.org/officeDocument/2006/relationships" xmlns:p="http://schemas.openxmlformats.org/presentationml/2006/main">
+<p:sld xmlns:a="http://schemas.openxmlformats.org/drawingml/2006/main" xmlns:p="http://schemas.openxmlformats.org/presentationml/2006/main" xmlns:r="http://schemas.openxmlformats.org/officeDocument/2006/relationships">
   <p:cSld>
     <p:spTree>
       <p:nvGrpSpPr>
@@ -6442,14 +6335,7 @@
         <p:cNvGrpSpPr/>
         <p:nvPr/>
       </p:nvGrpSpPr>
-      <p:grpSpPr>
-        <a:xfrm>
-          <a:off x="0" y="0"/>
-          <a:ext cx="0" cy="0"/>
-          <a:chOff x="0" y="0"/>
-          <a:chExt cx="0" cy="0"/>
-        </a:xfrm>
-      </p:grpSpPr>
+      <p:grpSpPr/>
       <p:sp>
         <p:nvSpPr>
           <p:cNvPr id="2" name="Rectangle 1"/>
@@ -6492,7 +6378,6 @@
           <a:lstStyle/>
           <a:p>
             <a:pPr algn="ctr"/>
-            <a:endParaRPr/>
           </a:p>
         </p:txBody>
       </p:sp>
@@ -6513,7 +6398,7 @@
           <a:noFill/>
         </p:spPr>
         <p:txBody>
-          <a:bodyPr wrap="square" lIns="0" tIns="0" rIns="0" bIns="0">
+          <a:bodyPr wrap="square" lIns="0" rIns="0" tIns="0" bIns="0">
             <a:spAutoFit/>
           </a:bodyPr>
           <a:lstStyle/>
@@ -6549,7 +6434,7 @@
           <a:noFill/>
         </p:spPr>
         <p:txBody>
-          <a:bodyPr wrap="square" lIns="0" tIns="0" rIns="0" bIns="0">
+          <a:bodyPr wrap="square" lIns="0" rIns="0" tIns="0" bIns="0">
             <a:spAutoFit/>
           </a:bodyPr>
           <a:lstStyle/>
@@ -6610,7 +6495,6 @@
           <a:lstStyle/>
           <a:p>
             <a:pPr algn="ctr"/>
-            <a:endParaRPr/>
           </a:p>
         </p:txBody>
       </p:sp>
@@ -6729,7 +6613,6 @@
           <a:lstStyle/>
           <a:p>
             <a:pPr algn="ctr"/>
-            <a:endParaRPr/>
           </a:p>
         </p:txBody>
       </p:sp>
@@ -6848,7 +6731,6 @@
           <a:lstStyle/>
           <a:p>
             <a:pPr algn="ctr"/>
-            <a:endParaRPr/>
           </a:p>
         </p:txBody>
       </p:sp>
@@ -6967,7 +6849,6 @@
           <a:lstStyle/>
           <a:p>
             <a:pPr algn="ctr"/>
-            <a:endParaRPr/>
           </a:p>
         </p:txBody>
       </p:sp>
@@ -7053,7 +6934,7 @@
 </file>
 
 <file path=ppt/slides/slide6.xml><?xml version="1.0" encoding="utf-8"?>
-<p:sld xmlns:a="http://schemas.openxmlformats.org/drawingml/2006/main" xmlns:r="http://schemas.openxmlformats.org/officeDocument/2006/relationships" xmlns:p="http://schemas.openxmlformats.org/presentationml/2006/main">
+<p:sld xmlns:a="http://schemas.openxmlformats.org/drawingml/2006/main" xmlns:p="http://schemas.openxmlformats.org/presentationml/2006/main" xmlns:r="http://schemas.openxmlformats.org/officeDocument/2006/relationships">
   <p:cSld>
     <p:spTree>
       <p:nvGrpSpPr>
@@ -7061,14 +6942,7 @@
         <p:cNvGrpSpPr/>
         <p:nvPr/>
       </p:nvGrpSpPr>
-      <p:grpSpPr>
-        <a:xfrm>
-          <a:off x="0" y="0"/>
-          <a:ext cx="0" cy="0"/>
-          <a:chOff x="0" y="0"/>
-          <a:chExt cx="0" cy="0"/>
-        </a:xfrm>
-      </p:grpSpPr>
+      <p:grpSpPr/>
       <p:sp>
         <p:nvSpPr>
           <p:cNvPr id="2" name="Rectangle 1"/>
@@ -7111,7 +6985,6 @@
           <a:lstStyle/>
           <a:p>
             <a:pPr algn="ctr"/>
-            <a:endParaRPr/>
           </a:p>
         </p:txBody>
       </p:sp>
@@ -7132,7 +7005,7 @@
           <a:noFill/>
         </p:spPr>
         <p:txBody>
-          <a:bodyPr wrap="square" lIns="0" tIns="0" rIns="0" bIns="0">
+          <a:bodyPr wrap="square" lIns="0" rIns="0" tIns="0" bIns="0">
             <a:spAutoFit/>
           </a:bodyPr>
           <a:lstStyle/>
@@ -7168,7 +7041,7 @@
           <a:noFill/>
         </p:spPr>
         <p:txBody>
-          <a:bodyPr wrap="square" lIns="0" tIns="0" rIns="0" bIns="0">
+          <a:bodyPr wrap="square" lIns="0" rIns="0" tIns="0" bIns="0">
             <a:spAutoFit/>
           </a:bodyPr>
           <a:lstStyle/>
@@ -7229,7 +7102,6 @@
           <a:lstStyle/>
           <a:p>
             <a:pPr algn="ctr"/>
-            <a:endParaRPr/>
           </a:p>
         </p:txBody>
       </p:sp>
@@ -7400,7 +7272,6 @@
           <a:lstStyle/>
           <a:p>
             <a:pPr algn="ctr"/>
-            <a:endParaRPr/>
           </a:p>
         </p:txBody>
       </p:sp>
@@ -7571,7 +7442,6 @@
           <a:lstStyle/>
           <a:p>
             <a:pPr algn="ctr"/>
-            <a:endParaRPr/>
           </a:p>
         </p:txBody>
       </p:sp>
@@ -7742,7 +7612,6 @@
           <a:lstStyle/>
           <a:p>
             <a:pPr algn="ctr"/>
-            <a:endParaRPr/>
           </a:p>
         </p:txBody>
       </p:sp>
@@ -7880,7 +7749,7 @@
 </file>
 
 <file path=ppt/slides/slide7.xml><?xml version="1.0" encoding="utf-8"?>
-<p:sld xmlns:a="http://schemas.openxmlformats.org/drawingml/2006/main" xmlns:r="http://schemas.openxmlformats.org/officeDocument/2006/relationships" xmlns:p="http://schemas.openxmlformats.org/presentationml/2006/main">
+<p:sld xmlns:a="http://schemas.openxmlformats.org/drawingml/2006/main" xmlns:p="http://schemas.openxmlformats.org/presentationml/2006/main" xmlns:r="http://schemas.openxmlformats.org/officeDocument/2006/relationships">
   <p:cSld>
     <p:spTree>
       <p:nvGrpSpPr>
@@ -7888,14 +7757,7 @@
         <p:cNvGrpSpPr/>
         <p:nvPr/>
       </p:nvGrpSpPr>
-      <p:grpSpPr>
-        <a:xfrm>
-          <a:off x="0" y="0"/>
-          <a:ext cx="0" cy="0"/>
-          <a:chOff x="0" y="0"/>
-          <a:chExt cx="0" cy="0"/>
-        </a:xfrm>
-      </p:grpSpPr>
+      <p:grpSpPr/>
       <p:sp>
         <p:nvSpPr>
           <p:cNvPr id="2" name="Rectangle 1"/>
@@ -7938,7 +7800,6 @@
           <a:lstStyle/>
           <a:p>
             <a:pPr algn="ctr"/>
-            <a:endParaRPr/>
           </a:p>
         </p:txBody>
       </p:sp>
@@ -7959,7 +7820,7 @@
           <a:noFill/>
         </p:spPr>
         <p:txBody>
-          <a:bodyPr wrap="square" lIns="0" tIns="0" rIns="0" bIns="0">
+          <a:bodyPr wrap="square" lIns="0" rIns="0" tIns="0" bIns="0">
             <a:spAutoFit/>
           </a:bodyPr>
           <a:lstStyle/>
@@ -7995,7 +7856,7 @@
           <a:noFill/>
         </p:spPr>
         <p:txBody>
-          <a:bodyPr wrap="square" lIns="0" tIns="0" rIns="0" bIns="0">
+          <a:bodyPr wrap="square" lIns="0" rIns="0" tIns="0" bIns="0">
             <a:spAutoFit/>
           </a:bodyPr>
           <a:lstStyle/>
@@ -8056,7 +7917,6 @@
           <a:lstStyle/>
           <a:p>
             <a:pPr algn="ctr"/>
-            <a:endParaRPr/>
           </a:p>
         </p:txBody>
       </p:sp>
@@ -8171,7 +8031,6 @@
           <a:lstStyle/>
           <a:p>
             <a:pPr algn="ctr"/>
-            <a:endParaRPr/>
           </a:p>
         </p:txBody>
       </p:sp>
@@ -8279,7 +8138,6 @@
           <a:lstStyle/>
           <a:p>
             <a:pPr algn="ctr"/>
-            <a:endParaRPr/>
           </a:p>
         </p:txBody>
       </p:sp>
@@ -8361,7 +8219,7 @@
 </file>
 
 <file path=ppt/slides/slide8.xml><?xml version="1.0" encoding="utf-8"?>
-<p:sld xmlns:a="http://schemas.openxmlformats.org/drawingml/2006/main" xmlns:r="http://schemas.openxmlformats.org/officeDocument/2006/relationships" xmlns:p="http://schemas.openxmlformats.org/presentationml/2006/main">
+<p:sld xmlns:a="http://schemas.openxmlformats.org/drawingml/2006/main" xmlns:p="http://schemas.openxmlformats.org/presentationml/2006/main" xmlns:r="http://schemas.openxmlformats.org/officeDocument/2006/relationships">
   <p:cSld>
     <p:spTree>
       <p:nvGrpSpPr>
@@ -8369,14 +8227,7 @@
         <p:cNvGrpSpPr/>
         <p:nvPr/>
       </p:nvGrpSpPr>
-      <p:grpSpPr>
-        <a:xfrm>
-          <a:off x="0" y="0"/>
-          <a:ext cx="0" cy="0"/>
-          <a:chOff x="0" y="0"/>
-          <a:chExt cx="0" cy="0"/>
-        </a:xfrm>
-      </p:grpSpPr>
+      <p:grpSpPr/>
       <p:sp>
         <p:nvSpPr>
           <p:cNvPr id="2" name="Rectangle 1"/>
@@ -8419,7 +8270,6 @@
           <a:lstStyle/>
           <a:p>
             <a:pPr algn="ctr"/>
-            <a:endParaRPr/>
           </a:p>
         </p:txBody>
       </p:sp>
@@ -8440,7 +8290,7 @@
           <a:noFill/>
         </p:spPr>
         <p:txBody>
-          <a:bodyPr wrap="square" lIns="0" tIns="0" rIns="0" bIns="0">
+          <a:bodyPr wrap="square" lIns="0" rIns="0" tIns="0" bIns="0">
             <a:spAutoFit/>
           </a:bodyPr>
           <a:lstStyle/>
@@ -8476,7 +8326,7 @@
           <a:noFill/>
         </p:spPr>
         <p:txBody>
-          <a:bodyPr wrap="square" lIns="0" tIns="0" rIns="0" bIns="0">
+          <a:bodyPr wrap="square" lIns="0" rIns="0" tIns="0" bIns="0">
             <a:spAutoFit/>
           </a:bodyPr>
           <a:lstStyle/>
@@ -8537,7 +8387,6 @@
           <a:lstStyle/>
           <a:p>
             <a:pPr algn="ctr"/>
-            <a:endParaRPr/>
           </a:p>
         </p:txBody>
       </p:sp>
@@ -8693,7 +8542,6 @@
           <a:lstStyle/>
           <a:p>
             <a:pPr algn="ctr"/>
-            <a:endParaRPr/>
           </a:p>
         </p:txBody>
       </p:sp>
@@ -8831,7 +8679,7 @@
 </file>
 
 <file path=ppt/slides/slide9.xml><?xml version="1.0" encoding="utf-8"?>
-<p:sld xmlns:a="http://schemas.openxmlformats.org/drawingml/2006/main" xmlns:r="http://schemas.openxmlformats.org/officeDocument/2006/relationships" xmlns:p="http://schemas.openxmlformats.org/presentationml/2006/main">
+<p:sld xmlns:a="http://schemas.openxmlformats.org/drawingml/2006/main" xmlns:p="http://schemas.openxmlformats.org/presentationml/2006/main" xmlns:r="http://schemas.openxmlformats.org/officeDocument/2006/relationships">
   <p:cSld>
     <p:spTree>
       <p:nvGrpSpPr>
@@ -8839,14 +8687,7 @@
         <p:cNvGrpSpPr/>
         <p:nvPr/>
       </p:nvGrpSpPr>
-      <p:grpSpPr>
-        <a:xfrm>
-          <a:off x="0" y="0"/>
-          <a:ext cx="0" cy="0"/>
-          <a:chOff x="0" y="0"/>
-          <a:chExt cx="0" cy="0"/>
-        </a:xfrm>
-      </p:grpSpPr>
+      <p:grpSpPr/>
       <p:sp>
         <p:nvSpPr>
           <p:cNvPr id="2" name="Rectangle 1"/>
@@ -8889,7 +8730,6 @@
           <a:lstStyle/>
           <a:p>
             <a:pPr algn="ctr"/>
-            <a:endParaRPr/>
           </a:p>
         </p:txBody>
       </p:sp>
@@ -8910,7 +8750,7 @@
           <a:noFill/>
         </p:spPr>
         <p:txBody>
-          <a:bodyPr wrap="square" lIns="0" tIns="0" rIns="0" bIns="0">
+          <a:bodyPr wrap="square" lIns="0" rIns="0" tIns="0" bIns="0">
             <a:spAutoFit/>
           </a:bodyPr>
           <a:lstStyle/>
@@ -8946,7 +8786,7 @@
           <a:noFill/>
         </p:spPr>
         <p:txBody>
-          <a:bodyPr wrap="square" lIns="0" tIns="0" rIns="0" bIns="0">
+          <a:bodyPr wrap="square" lIns="0" rIns="0" tIns="0" bIns="0">
             <a:spAutoFit/>
           </a:bodyPr>
           <a:lstStyle/>
@@ -9007,7 +8847,6 @@
           <a:lstStyle/>
           <a:p>
             <a:pPr algn="ctr"/>
-            <a:endParaRPr/>
           </a:p>
         </p:txBody>
       </p:sp>
@@ -9283,7 +9122,6 @@
           <a:lstStyle/>
           <a:p>
             <a:pPr algn="ctr"/>
-            <a:endParaRPr/>
           </a:p>
         </p:txBody>
       </p:sp>
@@ -9518,7 +9356,6 @@
           <a:lstStyle/>
           <a:p>
             <a:pPr algn="ctr"/>
-            <a:endParaRPr/>
           </a:p>
         </p:txBody>
       </p:sp>

</xml_diff>